<commit_message>
feat: integrate Dash with FastAPI for improved in-process communication
- Refactored main.py to streamline the health check and model readiness logic, removing unnecessary checks.
- Updated architecture documentation to reflect changes in the Dash integration, including a new simplified diagram.
- Enhanced make_deck.js to dynamically select the appropriate architecture diagram based on availability.
- Introduced a new function in app.py to bind Dash to the FastAPI application, enabling in-process communication without HTTP overhead.
</commit_message>
<xml_diff>
--- a/docs/livrables/Support_soutenance_POC_ElectioAnalytics.pptx
+++ b/docs/livrables/Support_soutenance_POC_ElectioAnalytics.pptx
@@ -2601,7 +2601,7 @@
                   <a:srgbClr val="0066CC"/>
                 </a:solidFill>
               </a:rPr>
-              <a:t>Gradient Boosting — holdout 2022 = 0,53 (données réelles)</a:t>
+              <a:t>Oracle 0,812 / tendance 0,448 — le modèle sait la carte, pas la vague</a:t>
             </a:r>
             <a:endParaRPr lang="en-US" sz="1400" dirty="0"/>
           </a:p>
@@ -2811,7 +2811,7 @@
                   <a:srgbClr val="222222"/>
                 </a:solidFill>
               </a:rPr>
-              <a:t>Holdout 2022 : 0,53 (&gt; 0,5)</a:t>
+              <a:t>Oracle MAE : 1,394</a:t>
             </a:r>
             <a:endParaRPr lang="en-US" sz="1250" dirty="0"/>
           </a:p>
@@ -2829,7 +2829,7 @@
                   <a:srgbClr val="222222"/>
                 </a:solidFill>
               </a:rPr>
-              <a:t>Walk-forward : 0,37</a:t>
+              <a:t>Oracle argmax : 0,812</a:t>
             </a:r>
             <a:endParaRPr lang="en-US" sz="1250" dirty="0"/>
           </a:p>
@@ -2847,7 +2847,7 @@
                   <a:srgbClr val="222222"/>
                 </a:solidFill>
               </a:rPr>
-              <a:t>CV géo secondaire : 0,72</a:t>
+              <a:t>Tendance argmax : 0,448</a:t>
             </a:r>
             <a:endParaRPr lang="en-US" sz="1250" dirty="0"/>
           </a:p>
@@ -2865,7 +2865,7 @@
                   <a:srgbClr val="222222"/>
                 </a:solidFill>
               </a:rPr>
-              <a:t>Baseline CV : 0,41</a:t>
+              <a:t>Persist. écart oracle : 0,844</a:t>
             </a:r>
             <a:endParaRPr lang="en-US" sz="1250" dirty="0"/>
           </a:p>
@@ -2883,7 +2883,7 @@
                   <a:srgbClr val="222222"/>
                 </a:solidFill>
               </a:rPr>
-              <a:t>Top feature : pct gagnant précédent</a:t>
+              <a:t>Gagnant précédent : 0,521</a:t>
             </a:r>
             <a:endParaRPr lang="en-US" sz="1250" dirty="0"/>
           </a:p>
@@ -2901,7 +2901,7 @@
                   <a:srgbClr val="222222"/>
                 </a:solidFill>
               </a:rPr>
-              <a:t>Pauvreté : 40 % GOLD, hors ML</a:t>
+              <a:t>Socio-éco : 12,8 % importance</a:t>
             </a:r>
             <a:endParaRPr lang="en-US" sz="1250" dirty="0"/>
           </a:p>
@@ -9482,7 +9482,7 @@
       </p:grpSpPr>
       <p:pic>
         <p:nvPicPr>
-          <p:cNvPr id="2" name="Image 0" descr="C:\Users\julie\Documents\mspr-rattrapage\docs\mspr\02_architecture\diagrams\archi_techno_electio.png">    </p:cNvPr>
+          <p:cNvPr id="2" name="Image 0" descr="C:\Users\julie\Documents\mspr-rattrapage\docs\mspr\02_architecture\diagrams\archi_simplifiee_electio.png">    </p:cNvPr>
           <p:cNvPicPr>
             <a:picLocks noChangeAspect="1"/>
           </p:cNvPicPr>
@@ -11458,7 +11458,7 @@
                   <a:srgbClr val="0066CC"/>
                 </a:solidFill>
               </a:rPr>
-              <a:t>Classification supervisée du bloc en tête</a:t>
+              <a:t>Régression des écarts + scénario national</a:t>
             </a:r>
             <a:endParaRPr lang="en-US" sz="1400" dirty="0"/>
           </a:p>
@@ -11639,7 +11639,7 @@
                   <a:srgbClr val="222222"/>
                 </a:solidFill>
               </a:rPr>
-              <a:t>Sélection : 0,4×walk-forward + 0,6×holdout</a:t>
+              <a:t>Sélection : walk-forward hors holdout uniquement</a:t>
             </a:r>
             <a:endParaRPr lang="en-US" sz="1250" dirty="0"/>
           </a:p>
@@ -11738,7 +11738,7 @@
                   <a:srgbClr val="0066CC"/>
                 </a:solidFill>
               </a:rPr>
-              <a:t>5 modèles comparés</a:t>
+              <a:t>4 modèles comparés</a:t>
             </a:r>
             <a:endParaRPr lang="en-US" sz="1600" dirty="0"/>
           </a:p>
@@ -11778,7 +11778,7 @@
                   <a:srgbClr val="222222"/>
                 </a:solidFill>
               </a:rPr>
-              <a:t>Baseline (classe majoritaire)</a:t>
+              <a:t>Persistance de l’écart</a:t>
             </a:r>
             <a:endParaRPr lang="en-US" sz="1250" dirty="0"/>
           </a:p>
@@ -11796,7 +11796,7 @@
                   <a:srgbClr val="222222"/>
                 </a:solidFill>
               </a:rPr>
-              <a:t>Régression logistique</a:t>
+              <a:t>Ridge écart par bloc</a:t>
             </a:r>
             <a:endParaRPr lang="en-US" sz="1250" dirty="0"/>
           </a:p>
@@ -11814,7 +11814,7 @@
                   <a:srgbClr val="222222"/>
                 </a:solidFill>
               </a:rPr>
-              <a:t>Arbre de décision</a:t>
+              <a:t>Ridge écart multi-sorties — retenu</a:t>
             </a:r>
             <a:endParaRPr lang="en-US" sz="1250" dirty="0"/>
           </a:p>
@@ -11832,25 +11832,7 @@
                   <a:srgbClr val="222222"/>
                 </a:solidFill>
               </a:rPr>
-              <a:t>Random Forest (fort en CV géo)</a:t>
-            </a:r>
-            <a:endParaRPr lang="en-US" sz="1250" dirty="0"/>
-          </a:p>
-          <a:p>
-            <a:pPr marL="342900" indent="-342900">
-              <a:spcAft>
-                <a:spcPts val="700"/>
-              </a:spcAft>
-              <a:buSzPct val="100000"/>
-              <a:buChar char="•"/>
-            </a:pPr>
-            <a:r>
-              <a:rPr lang="en-US" sz="1250" dirty="0">
-                <a:solidFill>
-                  <a:srgbClr val="222222"/>
-                </a:solidFill>
-              </a:rPr>
-              <a:t>Gradient Boosting — retenu (temporel)</a:t>
+              <a:t>Forêt écart multi-sorties</a:t>
             </a:r>
             <a:endParaRPr lang="en-US" sz="1250" dirty="0"/>
           </a:p>

</xml_diff>